<commit_message>
docs: integrate official Rootory sprout logo into PowerPoint presentation deck
- Added high-resolution Rootory brand emblem beside title on Slide 1
- Added persistent top-right brand watermark logo and label across Slides 2-6
</commit_message>
<xml_diff>
--- a/Rootory_Presentation.pptx
+++ b/Rootory_Presentation.pptx
@@ -3138,56 +3138,13 @@
       </p:sp>
       <p:sp>
         <p:nvSpPr>
-          <p:cNvPr id="3" name="Rectangle 2"/>
+          <p:cNvPr id="3" name="Rounded Rectangle 2"/>
           <p:cNvSpPr/>
           <p:nvPr/>
         </p:nvSpPr>
         <p:spPr>
           <a:xfrm>
-            <a:off x="731520" y="640080"/>
-            <a:ext cx="1097280" cy="73152"/>
-          </a:xfrm>
-          <a:prstGeom prst="rect">
-            <a:avLst/>
-          </a:prstGeom>
-          <a:solidFill>
-            <a:srgbClr val="52B788"/>
-          </a:solidFill>
-          <a:ln>
-            <a:noFill/>
-          </a:ln>
-        </p:spPr>
-        <p:style>
-          <a:lnRef idx="1">
-            <a:schemeClr val="accent1"/>
-          </a:lnRef>
-          <a:fillRef idx="3">
-            <a:schemeClr val="accent1"/>
-          </a:fillRef>
-          <a:effectRef idx="2">
-            <a:schemeClr val="accent1"/>
-          </a:effectRef>
-          <a:fontRef idx="minor">
-            <a:schemeClr val="lt1"/>
-          </a:fontRef>
-        </p:style>
-        <p:txBody>
-          <a:bodyPr rtlCol="0" anchor="ctr"/>
-          <a:lstStyle/>
-          <a:p>
-            <a:pPr algn="ctr"/>
-          </a:p>
-        </p:txBody>
-      </p:sp>
-      <p:sp>
-        <p:nvSpPr>
-          <p:cNvPr id="4" name="Rounded Rectangle 3"/>
-          <p:cNvSpPr/>
-          <p:nvPr/>
-        </p:nvSpPr>
-        <p:spPr>
-          <a:xfrm>
-            <a:off x="731520" y="914400"/>
+            <a:off x="731520" y="777240"/>
             <a:ext cx="4114800" cy="384048"/>
           </a:xfrm>
           <a:prstGeom prst="roundRect">
@@ -3233,6 +3190,30 @@
           </a:p>
         </p:txBody>
       </p:sp>
+      <p:pic>
+        <p:nvPicPr>
+          <p:cNvPr id="4" name="Picture 3" descr="icon-512.png"/>
+          <p:cNvPicPr>
+            <a:picLocks noChangeAspect="1"/>
+          </p:cNvPicPr>
+          <p:nvPr/>
+        </p:nvPicPr>
+        <p:blipFill>
+          <a:blip r:embed="rId2"/>
+          <a:stretch>
+            <a:fillRect/>
+          </a:stretch>
+        </p:blipFill>
+        <p:spPr>
+          <a:xfrm>
+            <a:off x="731520" y="1371600"/>
+            <a:ext cx="1280160" cy="1280160"/>
+          </a:xfrm>
+          <a:prstGeom prst="rect">
+            <a:avLst/>
+          </a:prstGeom>
+        </p:spPr>
+      </p:pic>
       <p:sp>
         <p:nvSpPr>
           <p:cNvPr id="5" name="TextBox 4"/>
@@ -3241,8 +3222,8 @@
         </p:nvSpPr>
         <p:spPr>
           <a:xfrm>
-            <a:off x="731520" y="1417320"/>
-            <a:ext cx="10698480" cy="1371600"/>
+            <a:off x="2240280" y="1234440"/>
+            <a:ext cx="9144000" cy="1463040"/>
           </a:xfrm>
           <a:prstGeom prst="rect">
             <a:avLst/>
@@ -3256,7 +3237,7 @@
           <a:lstStyle/>
           <a:p>
             <a:pPr>
-              <a:defRPr b="1" sz="5600">
+              <a:defRPr b="1" sz="5400">
                 <a:solidFill>
                   <a:srgbClr val="FFFFFF"/>
                 </a:solidFill>
@@ -3269,6 +3250,9 @@
           </a:p>
           <a:p>
             <a:pPr>
+              <a:spcBef>
+                <a:spcPts val="200"/>
+              </a:spcBef>
               <a:defRPr sz="2000">
                 <a:solidFill>
                   <a:srgbClr val="52B788"/>
@@ -3290,7 +3274,7 @@
         </p:nvSpPr>
         <p:spPr>
           <a:xfrm>
-            <a:off x="731520" y="3017520"/>
+            <a:off x="731520" y="2926080"/>
             <a:ext cx="10698480" cy="1508760"/>
           </a:xfrm>
           <a:prstGeom prst="roundRect">
@@ -3335,7 +3319,7 @@
         </p:nvSpPr>
         <p:spPr>
           <a:xfrm>
-            <a:off x="1005840" y="3154680"/>
+            <a:off x="1005840" y="3063240"/>
             <a:ext cx="10149840" cy="1234440"/>
           </a:xfrm>
           <a:prstGeom prst="rect">
@@ -3387,8 +3371,8 @@
         </p:nvSpPr>
         <p:spPr>
           <a:xfrm>
-            <a:off x="731520" y="4754880"/>
-            <a:ext cx="6217920" cy="1463040"/>
+            <a:off x="731520" y="4709160"/>
+            <a:ext cx="6217920" cy="1508760"/>
           </a:xfrm>
           <a:prstGeom prst="roundRect">
             <a:avLst/>
@@ -3432,8 +3416,8 @@
         </p:nvSpPr>
         <p:spPr>
           <a:xfrm>
-            <a:off x="960120" y="4892040"/>
-            <a:ext cx="5760720" cy="1188720"/>
+            <a:off x="960120" y="4846320"/>
+            <a:ext cx="5760720" cy="1234440"/>
           </a:xfrm>
           <a:prstGeom prst="rect">
             <a:avLst/>
@@ -3500,8 +3484,8 @@
         </p:nvSpPr>
         <p:spPr>
           <a:xfrm>
-            <a:off x="7132320" y="4754880"/>
-            <a:ext cx="4297680" cy="1463040"/>
+            <a:off x="7132320" y="4709160"/>
+            <a:ext cx="4297680" cy="1508760"/>
           </a:xfrm>
           <a:prstGeom prst="roundRect">
             <a:avLst/>
@@ -3545,8 +3529,8 @@
         </p:nvSpPr>
         <p:spPr>
           <a:xfrm>
-            <a:off x="7360920" y="4892040"/>
-            <a:ext cx="3840480" cy="1188720"/>
+            <a:off x="7360920" y="4846320"/>
+            <a:ext cx="3840480" cy="1234440"/>
           </a:xfrm>
           <a:prstGeom prst="rect">
             <a:avLst/>
@@ -3729,7 +3713,7 @@
         <p:spPr>
           <a:xfrm>
             <a:off x="731520" y="777240"/>
-            <a:ext cx="10698480" cy="868680"/>
+            <a:ext cx="9601200" cy="868680"/>
           </a:xfrm>
           <a:prstGeom prst="rect">
             <a:avLst/>
@@ -3772,9 +3756,68 @@
           </a:p>
         </p:txBody>
       </p:sp>
-      <p:sp>
-        <p:nvSpPr>
-          <p:cNvPr id="5" name="Rounded Rectangle 4"/>
+      <p:pic>
+        <p:nvPicPr>
+          <p:cNvPr id="5" name="Picture 4" descr="icon-512.png"/>
+          <p:cNvPicPr>
+            <a:picLocks noChangeAspect="1"/>
+          </p:cNvPicPr>
+          <p:nvPr/>
+        </p:nvPicPr>
+        <p:blipFill>
+          <a:blip r:embed="rId2"/>
+          <a:stretch>
+            <a:fillRect/>
+          </a:stretch>
+        </p:blipFill>
+        <p:spPr>
+          <a:xfrm>
+            <a:off x="10835640" y="384048"/>
+            <a:ext cx="594360" cy="594360"/>
+          </a:xfrm>
+          <a:prstGeom prst="rect">
+            <a:avLst/>
+          </a:prstGeom>
+        </p:spPr>
+      </p:pic>
+      <p:sp>
+        <p:nvSpPr>
+          <p:cNvPr id="6" name="TextBox 5"/>
+          <p:cNvSpPr txBox="1"/>
+          <p:nvPr/>
+        </p:nvSpPr>
+        <p:spPr>
+          <a:xfrm>
+            <a:off x="10424160" y="987552"/>
+            <a:ext cx="1371600" cy="274320"/>
+          </a:xfrm>
+          <a:prstGeom prst="rect">
+            <a:avLst/>
+          </a:prstGeom>
+          <a:noFill/>
+        </p:spPr>
+        <p:txBody>
+          <a:bodyPr wrap="none">
+            <a:spAutoFit/>
+          </a:bodyPr>
+          <a:lstStyle/>
+          <a:p>
+            <a:pPr algn="ctr"/>
+            <a:r>
+              <a:rPr b="1" sz="1000">
+                <a:solidFill>
+                  <a:srgbClr val="2D6A4F"/>
+                </a:solidFill>
+                <a:latin typeface="Calibri"/>
+              </a:rPr>
+              <a:t>rootory</a:t>
+            </a:r>
+          </a:p>
+        </p:txBody>
+      </p:sp>
+      <p:sp>
+        <p:nvSpPr>
+          <p:cNvPr id="7" name="Rounded Rectangle 6"/>
           <p:cNvSpPr/>
           <p:nvPr/>
         </p:nvSpPr>
@@ -3819,7 +3862,7 @@
       </p:sp>
       <p:sp>
         <p:nvSpPr>
-          <p:cNvPr id="6" name="TextBox 5"/>
+          <p:cNvPr id="8" name="TextBox 7"/>
           <p:cNvSpPr txBox="1"/>
           <p:nvPr/>
         </p:nvSpPr>
@@ -3961,7 +4004,7 @@
       </p:sp>
       <p:sp>
         <p:nvSpPr>
-          <p:cNvPr id="7" name="Rounded Rectangle 6"/>
+          <p:cNvPr id="9" name="Rounded Rectangle 8"/>
           <p:cNvSpPr/>
           <p:nvPr/>
         </p:nvSpPr>
@@ -4006,7 +4049,7 @@
       </p:sp>
       <p:sp>
         <p:nvSpPr>
-          <p:cNvPr id="8" name="TextBox 7"/>
+          <p:cNvPr id="10" name="TextBox 9"/>
           <p:cNvSpPr txBox="1"/>
           <p:nvPr/>
         </p:nvSpPr>
@@ -4148,7 +4191,7 @@
       </p:sp>
       <p:sp>
         <p:nvSpPr>
-          <p:cNvPr id="9" name="Rounded Rectangle 8"/>
+          <p:cNvPr id="11" name="Rounded Rectangle 10"/>
           <p:cNvSpPr/>
           <p:nvPr/>
         </p:nvSpPr>
@@ -4193,7 +4236,7 @@
       </p:sp>
       <p:sp>
         <p:nvSpPr>
-          <p:cNvPr id="10" name="TextBox 9"/>
+          <p:cNvPr id="12" name="TextBox 11"/>
           <p:cNvSpPr txBox="1"/>
           <p:nvPr/>
         </p:nvSpPr>
@@ -4457,7 +4500,7 @@
         <p:spPr>
           <a:xfrm>
             <a:off x="731520" y="777240"/>
-            <a:ext cx="10698480" cy="868680"/>
+            <a:ext cx="9601200" cy="868680"/>
           </a:xfrm>
           <a:prstGeom prst="rect">
             <a:avLst/>
@@ -4500,9 +4543,68 @@
           </a:p>
         </p:txBody>
       </p:sp>
-      <p:sp>
-        <p:nvSpPr>
-          <p:cNvPr id="5" name="Rounded Rectangle 4"/>
+      <p:pic>
+        <p:nvPicPr>
+          <p:cNvPr id="5" name="Picture 4" descr="icon-512.png"/>
+          <p:cNvPicPr>
+            <a:picLocks noChangeAspect="1"/>
+          </p:cNvPicPr>
+          <p:nvPr/>
+        </p:nvPicPr>
+        <p:blipFill>
+          <a:blip r:embed="rId2"/>
+          <a:stretch>
+            <a:fillRect/>
+          </a:stretch>
+        </p:blipFill>
+        <p:spPr>
+          <a:xfrm>
+            <a:off x="10835640" y="384048"/>
+            <a:ext cx="594360" cy="594360"/>
+          </a:xfrm>
+          <a:prstGeom prst="rect">
+            <a:avLst/>
+          </a:prstGeom>
+        </p:spPr>
+      </p:pic>
+      <p:sp>
+        <p:nvSpPr>
+          <p:cNvPr id="6" name="TextBox 5"/>
+          <p:cNvSpPr txBox="1"/>
+          <p:nvPr/>
+        </p:nvSpPr>
+        <p:spPr>
+          <a:xfrm>
+            <a:off x="10424160" y="987552"/>
+            <a:ext cx="1371600" cy="274320"/>
+          </a:xfrm>
+          <a:prstGeom prst="rect">
+            <a:avLst/>
+          </a:prstGeom>
+          <a:noFill/>
+        </p:spPr>
+        <p:txBody>
+          <a:bodyPr wrap="none">
+            <a:spAutoFit/>
+          </a:bodyPr>
+          <a:lstStyle/>
+          <a:p>
+            <a:pPr algn="ctr"/>
+            <a:r>
+              <a:rPr b="1" sz="1000">
+                <a:solidFill>
+                  <a:srgbClr val="2D6A4F"/>
+                </a:solidFill>
+                <a:latin typeface="Calibri"/>
+              </a:rPr>
+              <a:t>rootory</a:t>
+            </a:r>
+          </a:p>
+        </p:txBody>
+      </p:sp>
+      <p:sp>
+        <p:nvSpPr>
+          <p:cNvPr id="7" name="Rounded Rectangle 6"/>
           <p:cNvSpPr/>
           <p:nvPr/>
         </p:nvSpPr>
@@ -4547,7 +4649,7 @@
       </p:sp>
       <p:sp>
         <p:nvSpPr>
-          <p:cNvPr id="6" name="TextBox 5"/>
+          <p:cNvPr id="8" name="TextBox 7"/>
           <p:cNvSpPr txBox="1"/>
           <p:nvPr/>
         </p:nvSpPr>
@@ -4597,7 +4699,7 @@
       </p:sp>
       <p:sp>
         <p:nvSpPr>
-          <p:cNvPr id="7" name="Rounded Rectangle 6"/>
+          <p:cNvPr id="9" name="Rounded Rectangle 8"/>
           <p:cNvSpPr/>
           <p:nvPr/>
         </p:nvSpPr>
@@ -4642,7 +4744,7 @@
       </p:sp>
       <p:sp>
         <p:nvSpPr>
-          <p:cNvPr id="8" name="TextBox 7"/>
+          <p:cNvPr id="10" name="TextBox 9"/>
           <p:cNvSpPr txBox="1"/>
           <p:nvPr/>
         </p:nvSpPr>
@@ -4692,7 +4794,7 @@
       </p:sp>
       <p:sp>
         <p:nvSpPr>
-          <p:cNvPr id="9" name="Rounded Rectangle 8"/>
+          <p:cNvPr id="11" name="Rounded Rectangle 10"/>
           <p:cNvSpPr/>
           <p:nvPr/>
         </p:nvSpPr>
@@ -4737,7 +4839,7 @@
       </p:sp>
       <p:sp>
         <p:nvSpPr>
-          <p:cNvPr id="10" name="TextBox 9"/>
+          <p:cNvPr id="12" name="TextBox 11"/>
           <p:cNvSpPr txBox="1"/>
           <p:nvPr/>
         </p:nvSpPr>
@@ -4787,7 +4889,7 @@
       </p:sp>
       <p:sp>
         <p:nvSpPr>
-          <p:cNvPr id="11" name="Rounded Rectangle 10"/>
+          <p:cNvPr id="13" name="Rounded Rectangle 12"/>
           <p:cNvSpPr/>
           <p:nvPr/>
         </p:nvSpPr>
@@ -4832,7 +4934,7 @@
       </p:sp>
       <p:sp>
         <p:nvSpPr>
-          <p:cNvPr id="12" name="TextBox 11"/>
+          <p:cNvPr id="14" name="TextBox 13"/>
           <p:cNvSpPr txBox="1"/>
           <p:nvPr/>
         </p:nvSpPr>
@@ -4882,7 +4984,7 @@
       </p:sp>
       <p:sp>
         <p:nvSpPr>
-          <p:cNvPr id="13" name="Rounded Rectangle 12"/>
+          <p:cNvPr id="15" name="Rounded Rectangle 14"/>
           <p:cNvSpPr/>
           <p:nvPr/>
         </p:nvSpPr>
@@ -4925,7 +5027,7 @@
       </p:sp>
       <p:sp>
         <p:nvSpPr>
-          <p:cNvPr id="14" name="TextBox 13"/>
+          <p:cNvPr id="16" name="TextBox 15"/>
           <p:cNvSpPr txBox="1"/>
           <p:nvPr/>
         </p:nvSpPr>
@@ -5081,7 +5183,7 @@
         <p:spPr>
           <a:xfrm>
             <a:off x="731520" y="777240"/>
-            <a:ext cx="10698480" cy="868680"/>
+            <a:ext cx="9601200" cy="868680"/>
           </a:xfrm>
           <a:prstGeom prst="rect">
             <a:avLst/>
@@ -5124,9 +5226,68 @@
           </a:p>
         </p:txBody>
       </p:sp>
-      <p:sp>
-        <p:nvSpPr>
-          <p:cNvPr id="5" name="Rounded Rectangle 4"/>
+      <p:pic>
+        <p:nvPicPr>
+          <p:cNvPr id="5" name="Picture 4" descr="icon-512.png"/>
+          <p:cNvPicPr>
+            <a:picLocks noChangeAspect="1"/>
+          </p:cNvPicPr>
+          <p:nvPr/>
+        </p:nvPicPr>
+        <p:blipFill>
+          <a:blip r:embed="rId2"/>
+          <a:stretch>
+            <a:fillRect/>
+          </a:stretch>
+        </p:blipFill>
+        <p:spPr>
+          <a:xfrm>
+            <a:off x="10835640" y="384048"/>
+            <a:ext cx="594360" cy="594360"/>
+          </a:xfrm>
+          <a:prstGeom prst="rect">
+            <a:avLst/>
+          </a:prstGeom>
+        </p:spPr>
+      </p:pic>
+      <p:sp>
+        <p:nvSpPr>
+          <p:cNvPr id="6" name="TextBox 5"/>
+          <p:cNvSpPr txBox="1"/>
+          <p:nvPr/>
+        </p:nvSpPr>
+        <p:spPr>
+          <a:xfrm>
+            <a:off x="10424160" y="987552"/>
+            <a:ext cx="1371600" cy="274320"/>
+          </a:xfrm>
+          <a:prstGeom prst="rect">
+            <a:avLst/>
+          </a:prstGeom>
+          <a:noFill/>
+        </p:spPr>
+        <p:txBody>
+          <a:bodyPr wrap="none">
+            <a:spAutoFit/>
+          </a:bodyPr>
+          <a:lstStyle/>
+          <a:p>
+            <a:pPr algn="ctr"/>
+            <a:r>
+              <a:rPr b="1" sz="1000">
+                <a:solidFill>
+                  <a:srgbClr val="2D6A4F"/>
+                </a:solidFill>
+                <a:latin typeface="Calibri"/>
+              </a:rPr>
+              <a:t>rootory</a:t>
+            </a:r>
+          </a:p>
+        </p:txBody>
+      </p:sp>
+      <p:sp>
+        <p:nvSpPr>
+          <p:cNvPr id="7" name="Rounded Rectangle 6"/>
           <p:cNvSpPr/>
           <p:nvPr/>
         </p:nvSpPr>
@@ -5171,7 +5332,7 @@
       </p:sp>
       <p:sp>
         <p:nvSpPr>
-          <p:cNvPr id="6" name="TextBox 5"/>
+          <p:cNvPr id="8" name="TextBox 7"/>
           <p:cNvSpPr txBox="1"/>
           <p:nvPr/>
         </p:nvSpPr>
@@ -5313,7 +5474,7 @@
       </p:sp>
       <p:sp>
         <p:nvSpPr>
-          <p:cNvPr id="7" name="Rounded Rectangle 6"/>
+          <p:cNvPr id="9" name="Rounded Rectangle 8"/>
           <p:cNvSpPr/>
           <p:nvPr/>
         </p:nvSpPr>
@@ -5358,7 +5519,7 @@
       </p:sp>
       <p:sp>
         <p:nvSpPr>
-          <p:cNvPr id="8" name="TextBox 7"/>
+          <p:cNvPr id="10" name="TextBox 9"/>
           <p:cNvSpPr txBox="1"/>
           <p:nvPr/>
         </p:nvSpPr>
@@ -5500,7 +5661,7 @@
       </p:sp>
       <p:sp>
         <p:nvSpPr>
-          <p:cNvPr id="9" name="Rounded Rectangle 8"/>
+          <p:cNvPr id="11" name="Rounded Rectangle 10"/>
           <p:cNvSpPr/>
           <p:nvPr/>
         </p:nvSpPr>
@@ -5545,7 +5706,7 @@
       </p:sp>
       <p:sp>
         <p:nvSpPr>
-          <p:cNvPr id="10" name="TextBox 9"/>
+          <p:cNvPr id="12" name="TextBox 11"/>
           <p:cNvSpPr txBox="1"/>
           <p:nvPr/>
         </p:nvSpPr>
@@ -5687,7 +5848,7 @@
       </p:sp>
       <p:sp>
         <p:nvSpPr>
-          <p:cNvPr id="11" name="Rounded Rectangle 10"/>
+          <p:cNvPr id="13" name="Rounded Rectangle 12"/>
           <p:cNvSpPr/>
           <p:nvPr/>
         </p:nvSpPr>
@@ -5732,7 +5893,7 @@
       </p:sp>
       <p:sp>
         <p:nvSpPr>
-          <p:cNvPr id="12" name="TextBox 11"/>
+          <p:cNvPr id="14" name="TextBox 13"/>
           <p:cNvSpPr txBox="1"/>
           <p:nvPr/>
         </p:nvSpPr>
@@ -5996,7 +6157,7 @@
         <p:spPr>
           <a:xfrm>
             <a:off x="731520" y="777240"/>
-            <a:ext cx="10698480" cy="868680"/>
+            <a:ext cx="9601200" cy="868680"/>
           </a:xfrm>
           <a:prstGeom prst="rect">
             <a:avLst/>
@@ -6039,9 +6200,68 @@
           </a:p>
         </p:txBody>
       </p:sp>
-      <p:sp>
-        <p:nvSpPr>
-          <p:cNvPr id="5" name="Rounded Rectangle 4"/>
+      <p:pic>
+        <p:nvPicPr>
+          <p:cNvPr id="5" name="Picture 4" descr="icon-512.png"/>
+          <p:cNvPicPr>
+            <a:picLocks noChangeAspect="1"/>
+          </p:cNvPicPr>
+          <p:nvPr/>
+        </p:nvPicPr>
+        <p:blipFill>
+          <a:blip r:embed="rId2"/>
+          <a:stretch>
+            <a:fillRect/>
+          </a:stretch>
+        </p:blipFill>
+        <p:spPr>
+          <a:xfrm>
+            <a:off x="10835640" y="384048"/>
+            <a:ext cx="594360" cy="594360"/>
+          </a:xfrm>
+          <a:prstGeom prst="rect">
+            <a:avLst/>
+          </a:prstGeom>
+        </p:spPr>
+      </p:pic>
+      <p:sp>
+        <p:nvSpPr>
+          <p:cNvPr id="6" name="TextBox 5"/>
+          <p:cNvSpPr txBox="1"/>
+          <p:nvPr/>
+        </p:nvSpPr>
+        <p:spPr>
+          <a:xfrm>
+            <a:off x="10424160" y="987552"/>
+            <a:ext cx="1371600" cy="274320"/>
+          </a:xfrm>
+          <a:prstGeom prst="rect">
+            <a:avLst/>
+          </a:prstGeom>
+          <a:noFill/>
+        </p:spPr>
+        <p:txBody>
+          <a:bodyPr wrap="none">
+            <a:spAutoFit/>
+          </a:bodyPr>
+          <a:lstStyle/>
+          <a:p>
+            <a:pPr algn="ctr"/>
+            <a:r>
+              <a:rPr b="1" sz="1000">
+                <a:solidFill>
+                  <a:srgbClr val="2D6A4F"/>
+                </a:solidFill>
+                <a:latin typeface="Calibri"/>
+              </a:rPr>
+              <a:t>rootory</a:t>
+            </a:r>
+          </a:p>
+        </p:txBody>
+      </p:sp>
+      <p:sp>
+        <p:nvSpPr>
+          <p:cNvPr id="7" name="Rounded Rectangle 6"/>
           <p:cNvSpPr/>
           <p:nvPr/>
         </p:nvSpPr>
@@ -6086,7 +6306,7 @@
       </p:sp>
       <p:sp>
         <p:nvSpPr>
-          <p:cNvPr id="6" name="TextBox 5"/>
+          <p:cNvPr id="8" name="TextBox 7"/>
           <p:cNvSpPr txBox="1"/>
           <p:nvPr/>
         </p:nvSpPr>
@@ -6228,7 +6448,7 @@
       </p:sp>
       <p:sp>
         <p:nvSpPr>
-          <p:cNvPr id="7" name="Rounded Rectangle 6"/>
+          <p:cNvPr id="9" name="Rounded Rectangle 8"/>
           <p:cNvSpPr/>
           <p:nvPr/>
         </p:nvSpPr>
@@ -6273,7 +6493,7 @@
       </p:sp>
       <p:sp>
         <p:nvSpPr>
-          <p:cNvPr id="8" name="TextBox 7"/>
+          <p:cNvPr id="10" name="TextBox 9"/>
           <p:cNvSpPr txBox="1"/>
           <p:nvPr/>
         </p:nvSpPr>
@@ -6415,7 +6635,7 @@
       </p:sp>
       <p:sp>
         <p:nvSpPr>
-          <p:cNvPr id="9" name="Rounded Rectangle 8"/>
+          <p:cNvPr id="11" name="Rounded Rectangle 10"/>
           <p:cNvSpPr/>
           <p:nvPr/>
         </p:nvSpPr>
@@ -6460,7 +6680,7 @@
       </p:sp>
       <p:sp>
         <p:nvSpPr>
-          <p:cNvPr id="10" name="TextBox 9"/>
+          <p:cNvPr id="12" name="TextBox 11"/>
           <p:cNvSpPr txBox="1"/>
           <p:nvPr/>
         </p:nvSpPr>
@@ -6724,7 +6944,7 @@
         <p:spPr>
           <a:xfrm>
             <a:off x="731520" y="777240"/>
-            <a:ext cx="10698480" cy="868680"/>
+            <a:ext cx="9601200" cy="868680"/>
           </a:xfrm>
           <a:prstGeom prst="rect">
             <a:avLst/>
@@ -6767,9 +6987,68 @@
           </a:p>
         </p:txBody>
       </p:sp>
-      <p:sp>
-        <p:nvSpPr>
-          <p:cNvPr id="5" name="Rounded Rectangle 4"/>
+      <p:pic>
+        <p:nvPicPr>
+          <p:cNvPr id="5" name="Picture 4" descr="icon-512.png"/>
+          <p:cNvPicPr>
+            <a:picLocks noChangeAspect="1"/>
+          </p:cNvPicPr>
+          <p:nvPr/>
+        </p:nvPicPr>
+        <p:blipFill>
+          <a:blip r:embed="rId2"/>
+          <a:stretch>
+            <a:fillRect/>
+          </a:stretch>
+        </p:blipFill>
+        <p:spPr>
+          <a:xfrm>
+            <a:off x="10835640" y="384048"/>
+            <a:ext cx="594360" cy="594360"/>
+          </a:xfrm>
+          <a:prstGeom prst="rect">
+            <a:avLst/>
+          </a:prstGeom>
+        </p:spPr>
+      </p:pic>
+      <p:sp>
+        <p:nvSpPr>
+          <p:cNvPr id="6" name="TextBox 5"/>
+          <p:cNvSpPr txBox="1"/>
+          <p:nvPr/>
+        </p:nvSpPr>
+        <p:spPr>
+          <a:xfrm>
+            <a:off x="10424160" y="987552"/>
+            <a:ext cx="1371600" cy="274320"/>
+          </a:xfrm>
+          <a:prstGeom prst="rect">
+            <a:avLst/>
+          </a:prstGeom>
+          <a:noFill/>
+        </p:spPr>
+        <p:txBody>
+          <a:bodyPr wrap="none">
+            <a:spAutoFit/>
+          </a:bodyPr>
+          <a:lstStyle/>
+          <a:p>
+            <a:pPr algn="ctr"/>
+            <a:r>
+              <a:rPr b="1" sz="1000">
+                <a:solidFill>
+                  <a:srgbClr val="2D6A4F"/>
+                </a:solidFill>
+                <a:latin typeface="Calibri"/>
+              </a:rPr>
+              <a:t>rootory</a:t>
+            </a:r>
+          </a:p>
+        </p:txBody>
+      </p:sp>
+      <p:sp>
+        <p:nvSpPr>
+          <p:cNvPr id="7" name="Rounded Rectangle 6"/>
           <p:cNvSpPr/>
           <p:nvPr/>
         </p:nvSpPr>
@@ -6814,7 +7093,7 @@
       </p:sp>
       <p:sp>
         <p:nvSpPr>
-          <p:cNvPr id="6" name="TextBox 5"/>
+          <p:cNvPr id="8" name="TextBox 7"/>
           <p:cNvSpPr txBox="1"/>
           <p:nvPr/>
         </p:nvSpPr>
@@ -7002,7 +7281,7 @@
       </p:sp>
       <p:sp>
         <p:nvSpPr>
-          <p:cNvPr id="7" name="Rounded Rectangle 6"/>
+          <p:cNvPr id="9" name="Rounded Rectangle 8"/>
           <p:cNvSpPr/>
           <p:nvPr/>
         </p:nvSpPr>
@@ -7047,7 +7326,7 @@
       </p:sp>
       <p:sp>
         <p:nvSpPr>
-          <p:cNvPr id="8" name="TextBox 7"/>
+          <p:cNvPr id="10" name="TextBox 9"/>
           <p:cNvSpPr txBox="1"/>
           <p:nvPr/>
         </p:nvSpPr>

</xml_diff>

<commit_message>
docs: generate live QR code and embed into Slide 6 of presentation deck
- Generated branded QR code for https://rootory-seven.vercel.app
- Embedded live scannable QR card into Slide 6 for instant judge testing during pitch
</commit_message>
<xml_diff>
--- a/Rootory_Presentation.pptx
+++ b/Rootory_Presentation.pptx
@@ -7055,7 +7055,7 @@
         <p:spPr>
           <a:xfrm>
             <a:off x="731520" y="1737360"/>
-            <a:ext cx="5166360" cy="4663440"/>
+            <a:ext cx="4114800" cy="4663440"/>
           </a:xfrm>
           <a:prstGeom prst="roundRect">
             <a:avLst/>
@@ -7099,8 +7099,8 @@
         </p:nvSpPr>
         <p:spPr>
           <a:xfrm>
-            <a:off x="960120" y="1920240"/>
-            <a:ext cx="4709160" cy="4297680"/>
+            <a:off x="914400" y="1920240"/>
+            <a:ext cx="3749040" cy="4297680"/>
           </a:xfrm>
           <a:prstGeom prst="rect">
             <a:avLst/>
@@ -7121,13 +7121,13 @@
               </a:defRPr>
             </a:pPr>
             <a:r>
-              <a:t>WORKING PROTOTYPE EVIDENCE</a:t>
+              <a:t>VERIFIED PROTOTYPE</a:t>
             </a:r>
           </a:p>
           <a:p>
             <a:pPr>
               <a:spcBef>
-                <a:spcPts val="400"/>
+                <a:spcPts val="300"/>
               </a:spcBef>
               <a:defRPr b="1" sz="1500">
                 <a:solidFill>
@@ -7136,15 +7136,15 @@
               </a:defRPr>
             </a:pPr>
             <a:r>
-              <a:t>Fully Deployed &amp; Testable Today</a:t>
+              <a:t>Deployed &amp; Testable Today</a:t>
             </a:r>
           </a:p>
           <a:p>
             <a:pPr>
               <a:spcBef>
-                <a:spcPts val="700"/>
+                <a:spcPts val="600"/>
               </a:spcBef>
-              <a:defRPr sz="1150">
+              <a:defRPr sz="1100">
                 <a:solidFill>
                   <a:srgbClr val="5C6B5E"/>
                 </a:solidFill>
@@ -7156,18 +7156,18 @@
                   <a:srgbClr val="1C2826"/>
                 </a:solidFill>
               </a:rPr>
-              <a:t>✓ Live URL: </a:t>
-            </a:r>
-            <a:r>
-              <a:t>https://rootory-seven.vercel.app (Fast worldwide CDN deployment).</a:t>
+              <a:t>✓ Live Web App: </a:t>
+            </a:r>
+            <a:r>
+              <a:t>rootory-seven.vercel.app</a:t>
             </a:r>
           </a:p>
           <a:p>
             <a:pPr>
               <a:spcBef>
-                <a:spcPts val="700"/>
+                <a:spcPts val="600"/>
               </a:spcBef>
-              <a:defRPr sz="1150">
+              <a:defRPr sz="1100">
                 <a:solidFill>
                   <a:srgbClr val="5C6B5E"/>
                 </a:solidFill>
@@ -7179,18 +7179,18 @@
                   <a:srgbClr val="1C2826"/>
                 </a:solidFill>
               </a:rPr>
-              <a:t>✓ Judge Login Account: </a:t>
-            </a:r>
-            <a:r>
-              <a:t>Email: demo@rootory.example  |  Password: 123456</a:t>
+              <a:t>✓ Judge Login: </a:t>
+            </a:r>
+            <a:r>
+              <a:t>demo@rootory.example | 123456</a:t>
             </a:r>
           </a:p>
           <a:p>
             <a:pPr>
               <a:spcBef>
-                <a:spcPts val="700"/>
+                <a:spcPts val="600"/>
               </a:spcBef>
-              <a:defRPr sz="1150">
+              <a:defRPr sz="1100">
                 <a:solidFill>
                   <a:srgbClr val="5C6B5E"/>
                 </a:solidFill>
@@ -7202,18 +7202,18 @@
                   <a:srgbClr val="1C2826"/>
                 </a:solidFill>
               </a:rPr>
-              <a:t>✓ Pre-Seeded Cloud Data: </a:t>
-            </a:r>
-            <a:r>
-              <a:t>Pre-populated with 3 plants, 8 timeline logs, Gemini AI observation card, 5 care tasks, 5 community posts, and 6 marketplace listings.</a:t>
+              <a:t>✓ Pre-Seeded Data: </a:t>
+            </a:r>
+            <a:r>
+              <a:t>3 plants, 8 logs, AI observation card, 5 tasks, 5 posts, 6 listings.</a:t>
             </a:r>
           </a:p>
           <a:p>
             <a:pPr>
               <a:spcBef>
-                <a:spcPts val="700"/>
+                <a:spcPts val="600"/>
               </a:spcBef>
-              <a:defRPr sz="1150">
+              <a:defRPr sz="1100">
                 <a:solidFill>
                   <a:srgbClr val="5C6B5E"/>
                 </a:solidFill>
@@ -7225,18 +7225,18 @@
                   <a:srgbClr val="1C2826"/>
                 </a:solidFill>
               </a:rPr>
-              <a:t>✓ Verified Test Suite: </a:t>
-            </a:r>
-            <a:r>
-              <a:t>16/16 Vitest unit tests passing across domain logic, sensor telemetry, cloud schema boundaries, and live service APIs.</a:t>
+              <a:t>✓ 16/16 Unit Tests: </a:t>
+            </a:r>
+            <a:r>
+              <a:t>100% passing across domain, sensor, cloud &amp; services.</a:t>
             </a:r>
           </a:p>
           <a:p>
             <a:pPr>
               <a:spcBef>
-                <a:spcPts val="700"/>
+                <a:spcPts val="600"/>
               </a:spcBef>
-              <a:defRPr sz="1150">
+              <a:defRPr sz="1100">
                 <a:solidFill>
                   <a:srgbClr val="5C6B5E"/>
                 </a:solidFill>
@@ -7248,18 +7248,18 @@
                   <a:srgbClr val="1C2826"/>
                 </a:solidFill>
               </a:rPr>
-              <a:t>✓ Clean Next.js Build: </a:t>
-            </a:r>
-            <a:r>
-              <a:t>Compiles cleanly in under 1 second with Next.js Turbopack and zero TypeScript errors.</a:t>
+              <a:t>✓ Turbopack Build: </a:t>
+            </a:r>
+            <a:r>
+              <a:t>Compiles in &lt;1 second with zero TypeScript errors.</a:t>
             </a:r>
           </a:p>
           <a:p>
             <a:pPr>
               <a:spcBef>
-                <a:spcPts val="700"/>
+                <a:spcPts val="600"/>
               </a:spcBef>
-              <a:defRPr sz="1150">
+              <a:defRPr sz="1100">
                 <a:solidFill>
                   <a:srgbClr val="5C6B5E"/>
                 </a:solidFill>
@@ -7271,10 +7271,10 @@
                   <a:srgbClr val="1C2826"/>
                 </a:solidFill>
               </a:rPr>
-              <a:t>✓ Open Source Repository: </a:t>
-            </a:r>
-            <a:r>
-              <a:t>https://github.com/prithik25/Rootory with complete documentation, architecture diagrams, and setup instructions.</a:t>
+              <a:t>✓ Open Source: </a:t>
+            </a:r>
+            <a:r>
+              <a:t>github.com/prithik25/Rootory</a:t>
             </a:r>
           </a:p>
         </p:txBody>
@@ -7287,8 +7287,165 @@
         </p:nvSpPr>
         <p:spPr>
           <a:xfrm>
-            <a:off x="6263640" y="1737360"/>
-            <a:ext cx="5166360" cy="4663440"/>
+            <a:off x="5029200" y="1737360"/>
+            <a:ext cx="2468880" cy="4663440"/>
+          </a:xfrm>
+          <a:prstGeom prst="roundRect">
+            <a:avLst/>
+          </a:prstGeom>
+          <a:solidFill>
+            <a:srgbClr val="FFFFFF"/>
+          </a:solidFill>
+          <a:ln w="19050">
+            <a:solidFill>
+              <a:srgbClr val="52B788"/>
+            </a:solidFill>
+          </a:ln>
+        </p:spPr>
+        <p:style>
+          <a:lnRef idx="1">
+            <a:schemeClr val="accent1"/>
+          </a:lnRef>
+          <a:fillRef idx="3">
+            <a:schemeClr val="accent1"/>
+          </a:fillRef>
+          <a:effectRef idx="2">
+            <a:schemeClr val="accent1"/>
+          </a:effectRef>
+          <a:fontRef idx="minor">
+            <a:schemeClr val="lt1"/>
+          </a:fontRef>
+        </p:style>
+        <p:txBody>
+          <a:bodyPr rtlCol="0" anchor="ctr"/>
+          <a:lstStyle/>
+          <a:p>
+            <a:pPr algn="ctr"/>
+          </a:p>
+        </p:txBody>
+      </p:sp>
+      <p:sp>
+        <p:nvSpPr>
+          <p:cNvPr id="10" name="TextBox 9"/>
+          <p:cNvSpPr txBox="1"/>
+          <p:nvPr/>
+        </p:nvSpPr>
+        <p:spPr>
+          <a:xfrm>
+            <a:off x="5120640" y="1920240"/>
+            <a:ext cx="2286000" cy="731520"/>
+          </a:xfrm>
+          <a:prstGeom prst="rect">
+            <a:avLst/>
+          </a:prstGeom>
+          <a:noFill/>
+        </p:spPr>
+        <p:txBody>
+          <a:bodyPr wrap="square">
+            <a:spAutoFit/>
+          </a:bodyPr>
+          <a:lstStyle/>
+          <a:p>
+            <a:pPr algn="ctr"/>
+            <a:r>
+              <a:rPr b="1" sz="1200">
+                <a:solidFill>
+                  <a:srgbClr val="183E32"/>
+                </a:solidFill>
+              </a:rPr>
+              <a:t>SCAN TO TEST LIVE
+</a:t>
+            </a:r>
+            <a:r>
+              <a:rPr sz="950">
+                <a:solidFill>
+                  <a:srgbClr val="5C6B5E"/>
+                </a:solidFill>
+              </a:rPr>
+              <a:t>Open on your smartphone camera</a:t>
+            </a:r>
+          </a:p>
+        </p:txBody>
+      </p:sp>
+      <p:pic>
+        <p:nvPicPr>
+          <p:cNvPr id="11" name="Picture 10" descr="rootory-qr.png"/>
+          <p:cNvPicPr>
+            <a:picLocks noChangeAspect="1"/>
+          </p:cNvPicPr>
+          <p:nvPr/>
+        </p:nvPicPr>
+        <p:blipFill>
+          <a:blip r:embed="rId3"/>
+          <a:stretch>
+            <a:fillRect/>
+          </a:stretch>
+        </p:blipFill>
+        <p:spPr>
+          <a:xfrm>
+            <a:off x="5349240" y="2788920"/>
+            <a:ext cx="1828800" cy="1828800"/>
+          </a:xfrm>
+          <a:prstGeom prst="rect">
+            <a:avLst/>
+          </a:prstGeom>
+        </p:spPr>
+      </p:pic>
+      <p:sp>
+        <p:nvSpPr>
+          <p:cNvPr id="12" name="TextBox 11"/>
+          <p:cNvSpPr txBox="1"/>
+          <p:nvPr/>
+        </p:nvSpPr>
+        <p:spPr>
+          <a:xfrm>
+            <a:off x="5120640" y="4754880"/>
+            <a:ext cx="2286000" cy="1463040"/>
+          </a:xfrm>
+          <a:prstGeom prst="rect">
+            <a:avLst/>
+          </a:prstGeom>
+          <a:noFill/>
+        </p:spPr>
+        <p:txBody>
+          <a:bodyPr wrap="square">
+            <a:spAutoFit/>
+          </a:bodyPr>
+          <a:lstStyle/>
+          <a:p>
+            <a:pPr algn="ctr"/>
+            <a:r>
+              <a:rPr b="1" sz="1100">
+                <a:solidFill>
+                  <a:srgbClr val="2D6A4F"/>
+                </a:solidFill>
+              </a:rPr>
+              <a:t>rootory-seven.vercel.app
+</a:t>
+            </a:r>
+            <a:r>
+              <a:rPr sz="1000">
+                <a:solidFill>
+                  <a:srgbClr val="1C2826"/>
+                </a:solidFill>
+              </a:rPr>
+              <a:t>• Instant PWA Install
+• 100% Offline Ready
+• Pre-Loaded Demo Seed</a:t>
+            </a:r>
+          </a:p>
+        </p:txBody>
+      </p:sp>
+      <p:sp>
+        <p:nvSpPr>
+          <p:cNvPr id="13" name="Rounded Rectangle 12"/>
+          <p:cNvSpPr/>
+          <p:nvPr/>
+        </p:nvSpPr>
+        <p:spPr>
+          <a:xfrm>
+            <a:off x="7680960" y="1737360"/>
+            <a:ext cx="3794760" cy="4663440"/>
           </a:xfrm>
           <a:prstGeom prst="roundRect">
             <a:avLst/>
@@ -7326,14 +7483,14 @@
       </p:sp>
       <p:sp>
         <p:nvSpPr>
-          <p:cNvPr id="10" name="TextBox 9"/>
+          <p:cNvPr id="14" name="TextBox 13"/>
           <p:cNvSpPr txBox="1"/>
           <p:nvPr/>
         </p:nvSpPr>
         <p:spPr>
           <a:xfrm>
-            <a:off x="6492240" y="1920240"/>
-            <a:ext cx="4709160" cy="4297680"/>
+            <a:off x="7863840" y="1920240"/>
+            <a:ext cx="3429000" cy="4297680"/>
           </a:xfrm>
           <a:prstGeom prst="rect">
             <a:avLst/>
@@ -7360,7 +7517,7 @@
           <a:p>
             <a:pPr>
               <a:spcBef>
-                <a:spcPts val="400"/>
+                <a:spcPts val="300"/>
               </a:spcBef>
               <a:defRPr b="1" sz="1500">
                 <a:solidFill>
@@ -7369,7 +7526,7 @@
               </a:defRPr>
             </a:pPr>
             <a:r>
-              <a:t>Future Scope Beyond the Prototype</a:t>
+              <a:t>Future Scope Beyond Demo</a:t>
             </a:r>
           </a:p>
           <a:p>
@@ -7377,7 +7534,7 @@
               <a:spcBef>
                 <a:spcPts val="700"/>
               </a:spcBef>
-              <a:defRPr sz="1150">
+              <a:defRPr sz="1100">
                 <a:solidFill>
                   <a:srgbClr val="5C6B5E"/>
                 </a:solidFill>
@@ -7389,10 +7546,10 @@
                   <a:srgbClr val="1C2826"/>
                 </a:solidFill>
               </a:rPr>
-              <a:t>➔ Multilingual &amp; Indic Voice UI: </a:t>
-            </a:r>
-            <a:r>
-              <a:t>Integrating voice-to-text and text-to-speech in Konkani, Marathi, and Hindi for non-literate rural farmers.</a:t>
+              <a:t>➔ Indic Voice UI: </a:t>
+            </a:r>
+            <a:r>
+              <a:t>Voice input in Konkani, Marathi &amp; Hindi for non-literate farmers.</a:t>
             </a:r>
           </a:p>
           <a:p>
@@ -7400,7 +7557,7 @@
               <a:spcBef>
                 <a:spcPts val="700"/>
               </a:spcBef>
-              <a:defRPr sz="1150">
+              <a:defRPr sz="1100">
                 <a:solidFill>
                   <a:srgbClr val="5C6B5E"/>
                 </a:solidFill>
@@ -7412,10 +7569,10 @@
                   <a:srgbClr val="1C2826"/>
                 </a:solidFill>
               </a:rPr>
-              <a:t>➔ P2P Mesh Network Sync: </a:t>
-            </a:r>
-            <a:r>
-              <a:t>Bluetooth Low Energy (BLE) and WiFi-Direct peer syncing for crop disease alerts across remote fields without cell towers.</a:t>
+              <a:t>➔ P2P Mesh Alerts: </a:t>
+            </a:r>
+            <a:r>
+              <a:t>BLE &amp; WiFi-Direct crop disease alert sharing across remote fields.</a:t>
             </a:r>
           </a:p>
           <a:p>
@@ -7423,7 +7580,7 @@
               <a:spcBef>
                 <a:spcPts val="700"/>
               </a:spcBef>
-              <a:defRPr sz="1150">
+              <a:defRPr sz="1100">
                 <a:solidFill>
                   <a:srgbClr val="5C6B5E"/>
                 </a:solidFill>
@@ -7435,10 +7592,10 @@
                   <a:srgbClr val="1C2826"/>
                 </a:solidFill>
               </a:rPr>
-              <a:t>➔ FPO Collective Logistics: </a:t>
-            </a:r>
-            <a:r>
-              <a:t>Pooling transport and delivery routes for Farmer Producer Organizations (FPOs) to service nearby city markets at scale.</a:t>
+              <a:t>➔ FPO Logistics: </a:t>
+            </a:r>
+            <a:r>
+              <a:t>Shared transport pooling for Farmer Producer Organizations.</a:t>
             </a:r>
           </a:p>
           <a:p>
@@ -7446,7 +7603,7 @@
               <a:spcBef>
                 <a:spcPts val="700"/>
               </a:spcBef>
-              <a:defRPr sz="1150">
+              <a:defRPr sz="1100">
                 <a:solidFill>
                   <a:srgbClr val="5C6B5E"/>
                 </a:solidFill>
@@ -7458,10 +7615,10 @@
                   <a:srgbClr val="1C2826"/>
                 </a:solidFill>
               </a:rPr>
-              <a:t>➔ Automated IoT Drip Control: </a:t>
-            </a:r>
-            <a:r>
-              <a:t>Closing the sensor loop by sending MQTT commands from moisture readings to solar-powered solenoid irrigation valves.</a:t>
+              <a:t>➔ IoT Drip Control: </a:t>
+            </a:r>
+            <a:r>
+              <a:t>Automated MQTT solenoid valve triggers from soil moisture.</a:t>
             </a:r>
           </a:p>
           <a:p>
@@ -7469,7 +7626,7 @@
               <a:spcBef>
                 <a:spcPts val="700"/>
               </a:spcBef>
-              <a:defRPr sz="1150">
+              <a:defRPr sz="1100">
                 <a:solidFill>
                   <a:srgbClr val="5C6B5E"/>
                 </a:solidFill>
@@ -7481,10 +7638,10 @@
                   <a:srgbClr val="1C2826"/>
                 </a:solidFill>
               </a:rPr>
-              <a:t>➔ Soil Carbon &amp; Agronomy Analytics: </a:t>
-            </a:r>
-            <a:r>
-              <a:t>Long-term soil health trend analysis helping smallholders qualify for regenerative agriculture carbon credits.</a:t>
+              <a:t>➔ Soil Carbon Data: </a:t>
+            </a:r>
+            <a:r>
+              <a:t>Long-term soil health analysis for regenerative carbon credits.</a:t>
             </a:r>
           </a:p>
         </p:txBody>

</xml_diff>